<commit_message>
fix: 同步 5/18 5/20 資料 + 重生提案 (192 樣本/67%) + 補修講稿 stale
問題 1: 本機落後線上 5 天
  - GitHub Actions 5/18 + 5/20 自動 commit 了新資料
  - 本機沒 git pull 所以 backtest 用舊 185 樣本算
  - 提案三件套上次重生時拉到舊數字

問題 2: 講稿 build_script.js 有 1 處硬寫 99 沒拉動態
  - line 204: 「在這 99 個樣本中」(範例語句)
  - 改為 ${SAMPLES} template literal

解決步驟:
1. git pull → 拉到 5/18, 5/20 daily
2. 不重跑 run_backtest (保留線上 192 樣本版避免微差)
3. 重生 3 件提案 (拉 192 樣本/67%/+2.42%)
4. 修補 build_script.js 第 204 行 stale 99
5. 重生 LINE post 2026-05-21

最終驗證:
  pptx:       67%×2 / 192×8 / +2.42×1  ✓
  提案書:     67%×5 / 192×11 / +2.42×3 ✓
  講稿:       67%×15 / 192×10 / +2.42×2  ✓ (stale 99 已修)

  data/backtest.json: 192 樣本 67% +2.42% (5/20 線上版)
  line_post/: 2026-05-21 觀察名單已產出

Co-Authored-By: Claude Opus 4.6 (1M context) <noreply@anthropic.com>
</commit_message>
<xml_diff>
--- a/proposal/股文觀指_商業簡報.pptx
+++ b/proposal/股文觀指_商業簡報.pptx
@@ -2794,7 +2794,7 @@
                 <a:ea typeface="Microsoft JhengHei" pitchFamily="34" charset="-122"/>
                 <a:cs typeface="Microsoft JhengHei" pitchFamily="34" charset="-120"/>
               </a:rPr>
-              <a:t>185 樣本 / 10 天 / 樣本加權 · 真實 TWSE OHLC</a:t>
+              <a:t>192 樣本 / 10 天 / 樣本加權 · 真實 TWSE OHLC</a:t>
             </a:r>
             <a:endParaRPr lang="en-US" sz="1100" dirty="0"/>
           </a:p>
@@ -4258,7 +4258,7 @@
                           <a:ea typeface="Microsoft JhengHei" pitchFamily="34" charset="-122"/>
                           <a:cs typeface="Microsoft JhengHei" pitchFamily="34" charset="-120"/>
                         </a:rPr>
-                        <a:t>✓ 185 樣本</a:t>
+                        <a:t>✓ 192 樣本</a:t>
                       </a:r>
                       <a:endParaRPr lang="en-US" sz="1200" dirty="0">
                         <a:latin typeface="Microsoft JhengHei" charset="0"/>
@@ -7553,7 +7553,7 @@
                 <a:ea typeface="Microsoft JhengHei" pitchFamily="34" charset="-122"/>
                 <a:cs typeface="Microsoft JhengHei" pitchFamily="34" charset="-120"/>
               </a:rPr>
-              <a:t>公開 70% 勝率、185 樣本回測、開源演算法，建立差異化信任</a:t>
+              <a:t>公開 67% 勝率、192 樣本回測、開源演算法，建立差異化信任</a:t>
             </a:r>
             <a:endParaRPr lang="en-US" sz="1200" dirty="0"/>
           </a:p>
@@ -8967,7 +8967,7 @@
                 <a:ea typeface="Microsoft JhengHei" pitchFamily="34" charset="-122"/>
                 <a:cs typeface="Microsoft JhengHei" pitchFamily="34" charset="-120"/>
               </a:rPr>
-              <a:t>目前回測僅 185 筆 / 10 天，未涵蓋多空頭循環。績效在不同市況下會有顯著差異。</a:t>
+              <a:t>目前回測僅 192 筆 / 10 天，未涵蓋多空頭循環。績效在不同市況下會有顯著差異。</a:t>
             </a:r>
             <a:endParaRPr lang="en-US" sz="1100" dirty="0"/>
           </a:p>
@@ -12856,7 +12856,7 @@
                 <a:ea typeface="Microsoft JhengHei" pitchFamily="34" charset="-122"/>
                 <a:cs typeface="Microsoft JhengHei" pitchFamily="34" charset="-120"/>
               </a:rPr>
-              <a:t>185</a:t>
+              <a:t>192</a:t>
             </a:r>
             <a:endParaRPr lang="en-US" sz="6000" dirty="0"/>
           </a:p>
@@ -14385,7 +14385,7 @@
                 <a:ea typeface="Microsoft JhengHei" pitchFamily="34" charset="-122"/>
                 <a:cs typeface="Microsoft JhengHei" pitchFamily="34" charset="-120"/>
               </a:rPr>
-              <a:t>回測結果（10 天 / 185 樣本）</a:t>
+              <a:t>回測結果（10 天 / 192 樣本）</a:t>
             </a:r>
             <a:endParaRPr lang="en-US" sz="1800" dirty="0"/>
           </a:p>
@@ -14463,7 +14463,7 @@
                 <a:ea typeface="Microsoft JhengHei" pitchFamily="34" charset="-122"/>
                 <a:cs typeface="Microsoft JhengHei" pitchFamily="34" charset="-120"/>
               </a:rPr>
-              <a:t>70%</a:t>
+              <a:t>67%</a:t>
             </a:r>
             <a:endParaRPr lang="en-US" sz="22000" dirty="0"/>
           </a:p>
@@ -14541,7 +14541,7 @@
                 <a:ea typeface="Microsoft JhengHei" pitchFamily="34" charset="-122"/>
                 <a:cs typeface="Microsoft JhengHei" pitchFamily="34" charset="-120"/>
               </a:rPr>
-              <a:t>130 / 185</a:t>
+              <a:t>128 / 192</a:t>
             </a:r>
             <a:endParaRPr lang="en-US" sz="2200" dirty="0"/>
           </a:p>
@@ -14619,7 +14619,7 @@
                 <a:ea typeface="Microsoft JhengHei" pitchFamily="34" charset="-122"/>
                 <a:cs typeface="Microsoft JhengHei" pitchFamily="34" charset="-120"/>
               </a:rPr>
-              <a:t>+2.58%</a:t>
+              <a:t>+2.42%</a:t>
             </a:r>
             <a:endParaRPr lang="en-US" sz="2200" dirty="0"/>
           </a:p>

</xml_diff>